<commit_message>
docs: switch to the narrated demo video and link it from the slides
- Demo_Video_Links.md and the report now point to https://youtu.be/N3cN5d2LSG4
  (6:51, English narration); the report header also lists the link.
- Slides 1 and 14 (Q&A) carry a clickable video link in the Marp source, the
  PowerPoint and the PDF.
- Re-export report/Report.pdf.

Co-Authored-By: Claude Opus 5.5 <noreply@anthropic.com>
</commit_message>
<xml_diff>
--- a/slides/Seminar_Slides.pptx
+++ b/slides/Seminar_Slides.pptx
@@ -3979,6 +3979,51 @@
           </a:p>
         </p:txBody>
       </p:sp>
+      <p:sp>
+        <p:nvSpPr>
+          <p:cNvPr id="12" name="TextBox 11"/>
+          <p:cNvSpPr txBox="1"/>
+          <p:nvPr/>
+        </p:nvSpPr>
+        <p:spPr>
+          <a:xfrm>
+            <a:off x="7315200" y="7726679"/>
+            <a:ext cx="9902952" cy="502920"/>
+          </a:xfrm>
+          <a:prstGeom prst="rect">
+            <a:avLst/>
+          </a:prstGeom>
+          <a:noFill/>
+        </p:spPr>
+        <p:txBody>
+          <a:bodyPr wrap="square">
+            <a:spAutoFit/>
+          </a:bodyPr>
+          <a:lstStyle/>
+          <a:p>
+            <a:pPr algn="l"/>
+            <a:r>
+              <a:rPr sz="2200" b="1">
+                <a:solidFill>
+                  <a:srgbClr val="1F4E79"/>
+                </a:solidFill>
+                <a:latin typeface="Arial"/>
+              </a:rPr>
+              <a:t>Video demo: </a:t>
+            </a:r>
+            <a:r>
+              <a:rPr sz="2200" b="1">
+                <a:solidFill>
+                  <a:srgbClr val="1F4E79"/>
+                </a:solidFill>
+                <a:latin typeface="Arial"/>
+                <a:hlinkClick r:id="rId4"/>
+              </a:rPr>
+              <a:t>https://youtu.be/N3cN5d2LSG4</a:t>
+            </a:r>
+          </a:p>
+        </p:txBody>
+      </p:sp>
     </p:spTree>
   </p:cSld>
   <p:clrMapOvr>
@@ -3987,7 +4032,7 @@
 </p:sld>
 </file>
 
-<file path=ppt/slides/slide11.xml><?xml version="1.0" encoding="utf-8"?>
+<file path=ppt/slides/slide10.xml><?xml version="1.0" encoding="utf-8"?>
 <p:sld xmlns:p="http://schemas.openxmlformats.org/presentationml/2006/main" xmlns:a="http://schemas.openxmlformats.org/drawingml/2006/main" xmlns:r="http://schemas.openxmlformats.org/officeDocument/2006/relationships">
   <p:cSld>
     <p:spTree>
@@ -6036,7 +6081,7 @@
 </p:sld>
 </file>
 
-<file path=ppt/slides/slide12.xml><?xml version="1.0" encoding="utf-8"?>
+<file path=ppt/slides/slide11.xml><?xml version="1.0" encoding="utf-8"?>
 <p:sld xmlns:p="http://schemas.openxmlformats.org/presentationml/2006/main" xmlns:a="http://schemas.openxmlformats.org/drawingml/2006/main" xmlns:r="http://schemas.openxmlformats.org/officeDocument/2006/relationships">
   <p:cSld>
     <p:spTree>
@@ -11804,6 +11849,815 @@
 </p:sld>
 </file>
 
+<file path=ppt/slides/slide12.xml><?xml version="1.0" encoding="utf-8"?>
+<p:sld xmlns:p="http://schemas.openxmlformats.org/presentationml/2006/main" xmlns:a="http://schemas.openxmlformats.org/drawingml/2006/main">
+  <p:cSld>
+    <p:spTree>
+      <p:nvGrpSpPr>
+        <p:cNvPr id="1" name=""/>
+        <p:cNvGrpSpPr/>
+        <p:nvPr/>
+      </p:nvGrpSpPr>
+      <p:grpSpPr>
+        <a:xfrm>
+          <a:off x="0" y="0"/>
+          <a:ext cx="0" cy="0"/>
+          <a:chOff x="0" y="0"/>
+          <a:chExt cx="0" cy="0"/>
+        </a:xfrm>
+      </p:grpSpPr>
+      <p:grpSp>
+        <p:nvGrpSpPr>
+          <p:cNvPr name="Group 2" id="2"/>
+          <p:cNvGrpSpPr/>
+          <p:nvPr/>
+        </p:nvGrpSpPr>
+        <p:grpSpPr>
+          <a:xfrm rot="0">
+            <a:off x="0" y="0"/>
+            <a:ext cx="18288181" cy="10287000"/>
+            <a:chOff x="0" y="0"/>
+            <a:chExt cx="24384241" cy="13716000"/>
+          </a:xfrm>
+        </p:grpSpPr>
+        <p:sp>
+          <p:nvSpPr>
+            <p:cNvPr name="Freeform 3" id="3"/>
+            <p:cNvSpPr/>
+            <p:nvPr/>
+          </p:nvSpPr>
+          <p:spPr>
+            <a:xfrm flipH="false" flipV="false" rot="0">
+              <a:off x="0" y="0"/>
+              <a:ext cx="24384254" cy="13716000"/>
+            </a:xfrm>
+            <a:custGeom>
+              <a:avLst/>
+              <a:gdLst/>
+              <a:ahLst/>
+              <a:cxnLst/>
+              <a:rect r="r" b="b" t="t" l="l"/>
+              <a:pathLst>
+                <a:path h="13716000" w="24384254">
+                  <a:moveTo>
+                    <a:pt x="0" y="0"/>
+                  </a:moveTo>
+                  <a:lnTo>
+                    <a:pt x="24384254" y="0"/>
+                  </a:lnTo>
+                  <a:lnTo>
+                    <a:pt x="24384254" y="13716000"/>
+                  </a:lnTo>
+                  <a:lnTo>
+                    <a:pt x="0" y="13716000"/>
+                  </a:lnTo>
+                  <a:lnTo>
+                    <a:pt x="0" y="0"/>
+                  </a:lnTo>
+                  <a:close/>
+                </a:path>
+              </a:pathLst>
+            </a:custGeom>
+            <a:solidFill>
+              <a:srgbClr val="FFFFFF"/>
+            </a:solidFill>
+          </p:spPr>
+        </p:sp>
+      </p:grpSp>
+      <p:grpSp>
+        <p:nvGrpSpPr>
+          <p:cNvPr name="Group 4" id="4"/>
+          <p:cNvGrpSpPr/>
+          <p:nvPr/>
+        </p:nvGrpSpPr>
+        <p:grpSpPr>
+          <a:xfrm rot="0">
+            <a:off x="0" y="0"/>
+            <a:ext cx="18288181" cy="10287000"/>
+            <a:chOff x="0" y="0"/>
+            <a:chExt cx="24384241" cy="13716000"/>
+          </a:xfrm>
+        </p:grpSpPr>
+        <p:sp>
+          <p:nvSpPr>
+            <p:cNvPr name="Freeform 5" id="5"/>
+            <p:cNvSpPr/>
+            <p:nvPr/>
+          </p:nvSpPr>
+          <p:spPr>
+            <a:xfrm flipH="false" flipV="false" rot="0">
+              <a:off x="0" y="0"/>
+              <a:ext cx="24384254" cy="13716000"/>
+            </a:xfrm>
+            <a:custGeom>
+              <a:avLst/>
+              <a:gdLst/>
+              <a:ahLst/>
+              <a:cxnLst/>
+              <a:rect r="r" b="b" t="t" l="l"/>
+              <a:pathLst>
+                <a:path h="13716000" w="24384254">
+                  <a:moveTo>
+                    <a:pt x="0" y="0"/>
+                  </a:moveTo>
+                  <a:lnTo>
+                    <a:pt x="24384254" y="0"/>
+                  </a:lnTo>
+                  <a:lnTo>
+                    <a:pt x="24384254" y="13716000"/>
+                  </a:lnTo>
+                  <a:lnTo>
+                    <a:pt x="0" y="13716000"/>
+                  </a:lnTo>
+                  <a:lnTo>
+                    <a:pt x="0" y="0"/>
+                  </a:lnTo>
+                  <a:close/>
+                </a:path>
+              </a:pathLst>
+            </a:custGeom>
+            <a:solidFill>
+              <a:srgbClr val="FFFFFF"/>
+            </a:solidFill>
+          </p:spPr>
+        </p:sp>
+      </p:grpSp>
+      <p:grpSp>
+        <p:nvGrpSpPr>
+          <p:cNvPr name="Group 6" id="6"/>
+          <p:cNvGrpSpPr/>
+          <p:nvPr/>
+        </p:nvGrpSpPr>
+        <p:grpSpPr>
+          <a:xfrm rot="0">
+            <a:off x="0" y="0"/>
+            <a:ext cx="18288181" cy="10287000"/>
+            <a:chOff x="0" y="0"/>
+            <a:chExt cx="24384241" cy="13716000"/>
+          </a:xfrm>
+        </p:grpSpPr>
+        <p:sp>
+          <p:nvSpPr>
+            <p:cNvPr name="Freeform 7" id="7"/>
+            <p:cNvSpPr/>
+            <p:nvPr/>
+          </p:nvSpPr>
+          <p:spPr>
+            <a:xfrm flipH="false" flipV="false" rot="0">
+              <a:off x="0" y="0"/>
+              <a:ext cx="24384254" cy="13716000"/>
+            </a:xfrm>
+            <a:custGeom>
+              <a:avLst/>
+              <a:gdLst/>
+              <a:ahLst/>
+              <a:cxnLst/>
+              <a:rect r="r" b="b" t="t" l="l"/>
+              <a:pathLst>
+                <a:path h="13716000" w="24384254">
+                  <a:moveTo>
+                    <a:pt x="0" y="0"/>
+                  </a:moveTo>
+                  <a:lnTo>
+                    <a:pt x="24384254" y="0"/>
+                  </a:lnTo>
+                  <a:lnTo>
+                    <a:pt x="24384254" y="13716000"/>
+                  </a:lnTo>
+                  <a:lnTo>
+                    <a:pt x="0" y="13716000"/>
+                  </a:lnTo>
+                  <a:lnTo>
+                    <a:pt x="0" y="0"/>
+                  </a:lnTo>
+                  <a:close/>
+                </a:path>
+              </a:pathLst>
+            </a:custGeom>
+            <a:solidFill>
+              <a:srgbClr val="FFFFFF"/>
+            </a:solidFill>
+          </p:spPr>
+        </p:sp>
+      </p:grpSp>
+      <p:grpSp>
+        <p:nvGrpSpPr>
+          <p:cNvPr name="Group 8" id="8"/>
+          <p:cNvGrpSpPr/>
+          <p:nvPr/>
+        </p:nvGrpSpPr>
+        <p:grpSpPr>
+          <a:xfrm rot="0">
+            <a:off x="685257" y="3157376"/>
+            <a:ext cx="8287379" cy="500577"/>
+            <a:chOff x="0" y="0"/>
+            <a:chExt cx="11049838" cy="667436"/>
+          </a:xfrm>
+        </p:grpSpPr>
+        <p:sp>
+          <p:nvSpPr>
+            <p:cNvPr name="Freeform 9" id="9"/>
+            <p:cNvSpPr/>
+            <p:nvPr/>
+          </p:nvSpPr>
+          <p:spPr>
+            <a:xfrm flipH="false" flipV="false" rot="0">
+              <a:off x="0" y="0"/>
+              <a:ext cx="11049889" cy="667385"/>
+            </a:xfrm>
+            <a:custGeom>
+              <a:avLst/>
+              <a:gdLst/>
+              <a:ahLst/>
+              <a:cxnLst/>
+              <a:rect r="r" b="b" t="t" l="l"/>
+              <a:pathLst>
+                <a:path h="667385" w="11049889">
+                  <a:moveTo>
+                    <a:pt x="0" y="0"/>
+                  </a:moveTo>
+                  <a:lnTo>
+                    <a:pt x="11049889" y="0"/>
+                  </a:lnTo>
+                  <a:lnTo>
+                    <a:pt x="11049889" y="667385"/>
+                  </a:lnTo>
+                  <a:lnTo>
+                    <a:pt x="0" y="667385"/>
+                  </a:lnTo>
+                  <a:lnTo>
+                    <a:pt x="0" y="0"/>
+                  </a:lnTo>
+                  <a:close/>
+                </a:path>
+              </a:pathLst>
+            </a:custGeom>
+            <a:solidFill>
+              <a:srgbClr val="1F4E79"/>
+            </a:solidFill>
+          </p:spPr>
+        </p:sp>
+      </p:grpSp>
+      <p:sp>
+        <p:nvSpPr>
+          <p:cNvPr name="TextBox 10" id="10"/>
+          <p:cNvSpPr txBox="true"/>
+          <p:nvPr/>
+        </p:nvSpPr>
+        <p:spPr>
+          <a:xfrm rot="0">
+            <a:off x="6077321" y="1126405"/>
+            <a:ext cx="6475363" cy="666750"/>
+          </a:xfrm>
+          <a:prstGeom prst="rect">
+            <a:avLst/>
+          </a:prstGeom>
+        </p:spPr>
+        <p:txBody>
+          <a:bodyPr anchor="t" rtlCol="false" tIns="0" lIns="0" bIns="0" rIns="0">
+            <a:spAutoFit/>
+          </a:bodyPr>
+          <a:lstStyle/>
+          <a:p>
+            <a:pPr algn="l">
+              <a:lnSpc>
+                <a:spcPts val="5130"/>
+              </a:lnSpc>
+            </a:pPr>
+            <a:r>
+              <a:rPr lang="en-US" b="true" sz="4275" spc="-1">
+                <a:solidFill>
+                  <a:srgbClr val="1F4E79"/>
+                </a:solidFill>
+                <a:latin typeface="Arial Bold"/>
+                <a:ea typeface="Arial Bold"/>
+                <a:cs typeface="Arial Bold"/>
+                <a:sym typeface="Arial Bold"/>
+              </a:rPr>
+              <a:t>Giới hạn của hai công cụ</a:t>
+            </a:r>
+          </a:p>
+        </p:txBody>
+      </p:sp>
+      <p:sp>
+        <p:nvSpPr>
+          <p:cNvPr name="TextBox 11" id="11"/>
+          <p:cNvSpPr txBox="true"/>
+          <p:nvPr/>
+        </p:nvSpPr>
+        <p:spPr>
+          <a:xfrm rot="0">
+            <a:off x="4323778" y="3231013"/>
+            <a:ext cx="1011422" cy="314087"/>
+          </a:xfrm>
+          <a:prstGeom prst="rect">
+            <a:avLst/>
+          </a:prstGeom>
+        </p:spPr>
+        <p:txBody>
+          <a:bodyPr anchor="t" rtlCol="false" tIns="0" lIns="0" bIns="0" rIns="0">
+            <a:spAutoFit/>
+          </a:bodyPr>
+          <a:lstStyle/>
+          <a:p>
+            <a:pPr algn="l">
+              <a:lnSpc>
+                <a:spcPts val="2574"/>
+              </a:lnSpc>
+            </a:pPr>
+            <a:r>
+              <a:rPr lang="en-US" b="true" sz="2145" spc="-1">
+                <a:solidFill>
+                  <a:srgbClr val="FFFFFF"/>
+                </a:solidFill>
+                <a:latin typeface="Arial Bold"/>
+                <a:ea typeface="Arial Bold"/>
+                <a:cs typeface="Arial Bold"/>
+                <a:sym typeface="Arial Bold"/>
+              </a:rPr>
+              <a:t>Appium</a:t>
+            </a:r>
+          </a:p>
+        </p:txBody>
+      </p:sp>
+      <p:sp>
+        <p:nvSpPr>
+          <p:cNvPr name="TextBox 12" id="12"/>
+          <p:cNvSpPr txBox="true"/>
+          <p:nvPr/>
+        </p:nvSpPr>
+        <p:spPr>
+          <a:xfrm rot="0">
+            <a:off x="685800" y="3795512"/>
+            <a:ext cx="8057772" cy="2124075"/>
+          </a:xfrm>
+          <a:prstGeom prst="rect">
+            <a:avLst/>
+          </a:prstGeom>
+        </p:spPr>
+        <p:txBody>
+          <a:bodyPr anchor="t" rtlCol="false" tIns="0" lIns="0" bIns="0" rIns="0">
+            <a:spAutoFit/>
+          </a:bodyPr>
+          <a:lstStyle/>
+          <a:p>
+            <a:pPr algn="l" marL="511683" indent="-255842" lvl="1">
+              <a:lnSpc>
+                <a:spcPts val="2844"/>
+              </a:lnSpc>
+              <a:buFont typeface="Arial"/>
+              <a:buChar char="•"/>
+            </a:pPr>
+            <a:r>
+              <a:rPr lang="en-US" sz="2370">
+                <a:solidFill>
+                  <a:srgbClr val="222222"/>
+                </a:solidFill>
+                <a:latin typeface="Arial"/>
+                <a:ea typeface="Arial"/>
+                <a:cs typeface="Arial"/>
+                <a:sym typeface="Arial"/>
+              </a:rPr>
+              <a:t>Không tự đánh giá giao diện – Functional tests có thể pass dù UI hiển thị sai.</a:t>
+            </a:r>
+          </a:p>
+          <a:p>
+            <a:pPr algn="l" marL="511683" indent="-255842" lvl="1">
+              <a:lnSpc>
+                <a:spcPts val="2844"/>
+              </a:lnSpc>
+              <a:buFont typeface="Arial"/>
+              <a:buChar char="•"/>
+            </a:pPr>
+            <a:r>
+              <a:rPr lang="en-US" sz="2370">
+                <a:solidFill>
+                  <a:srgbClr val="222222"/>
+                </a:solidFill>
+                <a:latin typeface="Arial"/>
+                <a:ea typeface="Arial"/>
+                <a:cs typeface="Arial"/>
+                <a:sym typeface="Arial"/>
+              </a:rPr>
+              <a:t>Nhạy cảm với thay đổi UI – Test scripts có thể cần bảo trì khi locators thay đổi.</a:t>
+            </a:r>
+          </a:p>
+          <a:p>
+            <a:pPr algn="l" marL="511683" indent="-255842" lvl="1">
+              <a:lnSpc>
+                <a:spcPts val="2844"/>
+              </a:lnSpc>
+              <a:buFont typeface="Arial"/>
+              <a:buChar char="•"/>
+            </a:pPr>
+            <a:r>
+              <a:rPr lang="en-US" sz="2370" spc="-1">
+                <a:solidFill>
+                  <a:srgbClr val="222222"/>
+                </a:solidFill>
+                <a:latin typeface="Arial"/>
+                <a:ea typeface="Arial"/>
+                <a:cs typeface="Arial"/>
+                <a:sym typeface="Arial"/>
+              </a:rPr>
+              <a:t>Phụ thuộc môi trường thực thi – Thiết bị, animation và thời gian tải có thể ảnh hưởng tính ổn định.</a:t>
+            </a:r>
+          </a:p>
+        </p:txBody>
+      </p:sp>
+      <p:grpSp>
+        <p:nvGrpSpPr>
+          <p:cNvPr name="Group 13" id="13"/>
+          <p:cNvGrpSpPr/>
+          <p:nvPr/>
+        </p:nvGrpSpPr>
+        <p:grpSpPr>
+          <a:xfrm rot="0">
+            <a:off x="9315002" y="3157376"/>
+            <a:ext cx="8287379" cy="500577"/>
+            <a:chOff x="0" y="0"/>
+            <a:chExt cx="11049838" cy="667436"/>
+          </a:xfrm>
+        </p:grpSpPr>
+        <p:sp>
+          <p:nvSpPr>
+            <p:cNvPr name="Freeform 14" id="14"/>
+            <p:cNvSpPr/>
+            <p:nvPr/>
+          </p:nvSpPr>
+          <p:spPr>
+            <a:xfrm flipH="false" flipV="false" rot="0">
+              <a:off x="0" y="0"/>
+              <a:ext cx="11049889" cy="667385"/>
+            </a:xfrm>
+            <a:custGeom>
+              <a:avLst/>
+              <a:gdLst/>
+              <a:ahLst/>
+              <a:cxnLst/>
+              <a:rect r="r" b="b" t="t" l="l"/>
+              <a:pathLst>
+                <a:path h="667385" w="11049889">
+                  <a:moveTo>
+                    <a:pt x="0" y="0"/>
+                  </a:moveTo>
+                  <a:lnTo>
+                    <a:pt x="11049889" y="0"/>
+                  </a:lnTo>
+                  <a:lnTo>
+                    <a:pt x="11049889" y="667385"/>
+                  </a:lnTo>
+                  <a:lnTo>
+                    <a:pt x="0" y="667385"/>
+                  </a:lnTo>
+                  <a:lnTo>
+                    <a:pt x="0" y="0"/>
+                  </a:lnTo>
+                  <a:close/>
+                </a:path>
+              </a:pathLst>
+            </a:custGeom>
+            <a:solidFill>
+              <a:srgbClr val="C00000"/>
+            </a:solidFill>
+          </p:spPr>
+        </p:sp>
+      </p:grpSp>
+      <p:sp>
+        <p:nvSpPr>
+          <p:cNvPr name="TextBox 15" id="15"/>
+          <p:cNvSpPr txBox="true"/>
+          <p:nvPr/>
+        </p:nvSpPr>
+        <p:spPr>
+          <a:xfrm rot="0">
+            <a:off x="12440517" y="3231013"/>
+            <a:ext cx="2040122" cy="314087"/>
+          </a:xfrm>
+          <a:prstGeom prst="rect">
+            <a:avLst/>
+          </a:prstGeom>
+        </p:spPr>
+        <p:txBody>
+          <a:bodyPr anchor="t" rtlCol="false" tIns="0" lIns="0" bIns="0" rIns="0">
+            <a:spAutoFit/>
+          </a:bodyPr>
+          <a:lstStyle/>
+          <a:p>
+            <a:pPr algn="l">
+              <a:lnSpc>
+                <a:spcPts val="2574"/>
+              </a:lnSpc>
+            </a:pPr>
+            <a:r>
+              <a:rPr lang="en-US" b="true" sz="2145" spc="-1">
+                <a:solidFill>
+                  <a:srgbClr val="FFFFFF"/>
+                </a:solidFill>
+                <a:latin typeface="Arial Bold"/>
+                <a:ea typeface="Arial Bold"/>
+                <a:cs typeface="Arial Bold"/>
+                <a:sym typeface="Arial Bold"/>
+              </a:rPr>
+              <a:t>Applitools Eyes</a:t>
+            </a:r>
+          </a:p>
+        </p:txBody>
+      </p:sp>
+      <p:grpSp>
+        <p:nvGrpSpPr>
+          <p:cNvPr name="Group 16" id="16"/>
+          <p:cNvGrpSpPr/>
+          <p:nvPr/>
+        </p:nvGrpSpPr>
+        <p:grpSpPr>
+          <a:xfrm rot="0">
+            <a:off x="0" y="0"/>
+            <a:ext cx="18288181" cy="143104"/>
+            <a:chOff x="0" y="0"/>
+            <a:chExt cx="24384241" cy="190805"/>
+          </a:xfrm>
+        </p:grpSpPr>
+        <p:sp>
+          <p:nvSpPr>
+            <p:cNvPr name="Freeform 17" id="17"/>
+            <p:cNvSpPr/>
+            <p:nvPr/>
+          </p:nvSpPr>
+          <p:spPr>
+            <a:xfrm flipH="false" flipV="false" rot="0">
+              <a:off x="0" y="0"/>
+              <a:ext cx="24384254" cy="190754"/>
+            </a:xfrm>
+            <a:custGeom>
+              <a:avLst/>
+              <a:gdLst/>
+              <a:ahLst/>
+              <a:cxnLst/>
+              <a:rect r="r" b="b" t="t" l="l"/>
+              <a:pathLst>
+                <a:path h="190754" w="24384254">
+                  <a:moveTo>
+                    <a:pt x="0" y="0"/>
+                  </a:moveTo>
+                  <a:lnTo>
+                    <a:pt x="24384254" y="0"/>
+                  </a:lnTo>
+                  <a:lnTo>
+                    <a:pt x="24384254" y="190754"/>
+                  </a:lnTo>
+                  <a:lnTo>
+                    <a:pt x="0" y="190754"/>
+                  </a:lnTo>
+                  <a:lnTo>
+                    <a:pt x="0" y="0"/>
+                  </a:lnTo>
+                  <a:close/>
+                </a:path>
+              </a:pathLst>
+            </a:custGeom>
+            <a:solidFill>
+              <a:srgbClr val="1F4E79"/>
+            </a:solidFill>
+          </p:spPr>
+        </p:sp>
+      </p:grpSp>
+      <p:grpSp>
+        <p:nvGrpSpPr>
+          <p:cNvPr name="Group 18" id="18"/>
+          <p:cNvGrpSpPr/>
+          <p:nvPr/>
+        </p:nvGrpSpPr>
+        <p:grpSpPr>
+          <a:xfrm rot="0">
+            <a:off x="0" y="9943557"/>
+            <a:ext cx="18288181" cy="343443"/>
+            <a:chOff x="0" y="0"/>
+            <a:chExt cx="24384241" cy="457924"/>
+          </a:xfrm>
+        </p:grpSpPr>
+        <p:sp>
+          <p:nvSpPr>
+            <p:cNvPr name="Freeform 19" id="19"/>
+            <p:cNvSpPr/>
+            <p:nvPr/>
+          </p:nvSpPr>
+          <p:spPr>
+            <a:xfrm flipH="false" flipV="false" rot="0">
+              <a:off x="0" y="0"/>
+              <a:ext cx="24384254" cy="457962"/>
+            </a:xfrm>
+            <a:custGeom>
+              <a:avLst/>
+              <a:gdLst/>
+              <a:ahLst/>
+              <a:cxnLst/>
+              <a:rect r="r" b="b" t="t" l="l"/>
+              <a:pathLst>
+                <a:path h="457962" w="24384254">
+                  <a:moveTo>
+                    <a:pt x="0" y="0"/>
+                  </a:moveTo>
+                  <a:lnTo>
+                    <a:pt x="24384254" y="0"/>
+                  </a:lnTo>
+                  <a:lnTo>
+                    <a:pt x="24384254" y="457962"/>
+                  </a:lnTo>
+                  <a:lnTo>
+                    <a:pt x="0" y="457962"/>
+                  </a:lnTo>
+                  <a:lnTo>
+                    <a:pt x="0" y="0"/>
+                  </a:lnTo>
+                  <a:close/>
+                </a:path>
+              </a:pathLst>
+            </a:custGeom>
+            <a:solidFill>
+              <a:srgbClr val="1F4E79"/>
+            </a:solidFill>
+          </p:spPr>
+        </p:sp>
+      </p:grpSp>
+      <p:sp>
+        <p:nvSpPr>
+          <p:cNvPr name="TextBox 20" id="20"/>
+          <p:cNvSpPr txBox="true"/>
+          <p:nvPr/>
+        </p:nvSpPr>
+        <p:spPr>
+          <a:xfrm rot="0">
+            <a:off x="685800" y="250755"/>
+            <a:ext cx="4865942" cy="215808"/>
+          </a:xfrm>
+          <a:prstGeom prst="rect">
+            <a:avLst/>
+          </a:prstGeom>
+        </p:spPr>
+        <p:txBody>
+          <a:bodyPr anchor="t" rtlCol="false" tIns="0" lIns="0" bIns="0" rIns="0">
+            <a:spAutoFit/>
+          </a:bodyPr>
+          <a:lstStyle/>
+          <a:p>
+            <a:pPr algn="l">
+              <a:lnSpc>
+                <a:spcPts val="1764"/>
+              </a:lnSpc>
+            </a:pPr>
+            <a:r>
+              <a:rPr lang="en-US" b="true" sz="1470" spc="-1">
+                <a:solidFill>
+                  <a:srgbClr val="1F4E79"/>
+                </a:solidFill>
+                <a:latin typeface="Arial Bold"/>
+                <a:ea typeface="Arial Bold"/>
+                <a:cs typeface="Arial Bold"/>
+                <a:sym typeface="Arial Bold"/>
+              </a:rPr>
+              <a:t>2026 AI-first · Seminar T03 · Mobile Automation Testing</a:t>
+            </a:r>
+          </a:p>
+        </p:txBody>
+      </p:sp>
+      <p:sp>
+        <p:nvSpPr>
+          <p:cNvPr name="TextBox 21" id="21"/>
+          <p:cNvSpPr txBox="true"/>
+          <p:nvPr/>
+        </p:nvSpPr>
+        <p:spPr>
+          <a:xfrm rot="0">
+            <a:off x="685800" y="9998488"/>
+            <a:ext cx="9144000" cy="211826"/>
+          </a:xfrm>
+          <a:prstGeom prst="rect">
+            <a:avLst/>
+          </a:prstGeom>
+        </p:spPr>
+        <p:txBody>
+          <a:bodyPr anchor="t" rtlCol="false" tIns="0" lIns="0" bIns="0" rIns="0" wrap="square">
+            <a:noAutofit/>
+          </a:bodyPr>
+          <a:lstStyle/>
+          <a:p>
+            <a:pPr algn="l">
+              <a:lnSpc>
+                <a:spcPts val="1620"/>
+              </a:lnSpc>
+            </a:pPr>
+            <a:r>
+              <a:rPr lang="en-US" b="true" sz="1350" spc="-1">
+                <a:solidFill>
+                  <a:srgbClr val="FFFFFF"/>
+                </a:solidFill>
+                <a:latin typeface="Arial Bold"/>
+                <a:ea typeface="Arial Bold"/>
+                <a:cs typeface="Arial Bold"/>
+                <a:sym typeface="Arial Bold"/>
+              </a:rPr>
+              <a:t>12 · Giới hạn</a:t>
+            </a:r>
+          </a:p>
+        </p:txBody>
+      </p:sp>
+      <p:sp>
+        <p:nvSpPr>
+          <p:cNvPr name="TextBox 22" id="22"/>
+          <p:cNvSpPr txBox="true"/>
+          <p:nvPr/>
+        </p:nvSpPr>
+        <p:spPr>
+          <a:xfrm rot="0">
+            <a:off x="9315002" y="3795512"/>
+            <a:ext cx="8057772" cy="2124075"/>
+          </a:xfrm>
+          <a:prstGeom prst="rect">
+            <a:avLst/>
+          </a:prstGeom>
+        </p:spPr>
+        <p:txBody>
+          <a:bodyPr anchor="t" rtlCol="false" tIns="0" lIns="0" bIns="0" rIns="0">
+            <a:spAutoFit/>
+          </a:bodyPr>
+          <a:lstStyle/>
+          <a:p>
+            <a:pPr algn="l" marL="511683" indent="-255842" lvl="1">
+              <a:lnSpc>
+                <a:spcPts val="2844"/>
+              </a:lnSpc>
+              <a:buFont typeface="Arial"/>
+              <a:buChar char="•"/>
+            </a:pPr>
+            <a:r>
+              <a:rPr lang="en-US" sz="2370">
+                <a:solidFill>
+                  <a:srgbClr val="222222"/>
+                </a:solidFill>
+                <a:latin typeface="Arial"/>
+                <a:ea typeface="Arial"/>
+                <a:cs typeface="Arial"/>
+                <a:sym typeface="Arial"/>
+              </a:rPr>
+              <a:t>Không kiểm tra đầy đủ chức năng – UI đúng không đảm bảo logic hoặc dữ liệu đúng.</a:t>
+            </a:r>
+          </a:p>
+          <a:p>
+            <a:pPr algn="l" marL="511683" indent="-255842" lvl="1">
+              <a:lnSpc>
+                <a:spcPts val="2844"/>
+              </a:lnSpc>
+              <a:buFont typeface="Arial"/>
+              <a:buChar char="•"/>
+            </a:pPr>
+            <a:r>
+              <a:rPr lang="en-US" sz="2370">
+                <a:solidFill>
+                  <a:srgbClr val="222222"/>
+                </a:solidFill>
+                <a:latin typeface="Arial"/>
+                <a:ea typeface="Arial"/>
+                <a:cs typeface="Arial"/>
+                <a:sym typeface="Arial"/>
+              </a:rPr>
+              <a:t>Cần phân biệt thay đổi và lỗi – Không phải visual difference nào cũng là bug.</a:t>
+            </a:r>
+          </a:p>
+          <a:p>
+            <a:pPr algn="l" marL="511683" indent="-255842" lvl="1">
+              <a:lnSpc>
+                <a:spcPts val="2844"/>
+              </a:lnSpc>
+              <a:buFont typeface="Arial"/>
+              <a:buChar char="•"/>
+            </a:pPr>
+            <a:r>
+              <a:rPr lang="en-US" sz="2370" spc="-1">
+                <a:solidFill>
+                  <a:srgbClr val="222222"/>
+                </a:solidFill>
+                <a:latin typeface="Arial"/>
+                <a:ea typeface="Arial"/>
+                <a:cs typeface="Arial"/>
+                <a:sym typeface="Arial"/>
+              </a:rPr>
+              <a:t>Cần quản lý baseline – Những thay đổi thiết kế hợp lệ phải được review và cập nhật.</a:t>
+            </a:r>
+          </a:p>
+        </p:txBody>
+      </p:sp>
+    </p:spTree>
+  </p:cSld>
+  <p:clrMapOvr>
+    <a:masterClrMapping/>
+  </p:clrMapOvr>
+  <p:transition spd="fast">
+    <p:fade/>
+  </p:transition>
+</p:sld>
+</file>
+
 <file path=ppt/slides/slide13.xml><?xml version="1.0" encoding="utf-8"?>
 <p:sld xmlns:p="http://schemas.openxmlformats.org/presentationml/2006/main" xmlns:a="http://schemas.openxmlformats.org/drawingml/2006/main">
   <p:cSld>
@@ -11995,74 +12849,16 @@
           </p:spPr>
         </p:sp>
       </p:grpSp>
-      <p:grpSp>
-        <p:nvGrpSpPr>
-          <p:cNvPr name="Group 8" id="8"/>
-          <p:cNvGrpSpPr/>
-          <p:nvPr/>
-        </p:nvGrpSpPr>
-        <p:grpSpPr>
-          <a:xfrm rot="0">
-            <a:off x="685257" y="3157376"/>
-            <a:ext cx="8287379" cy="500577"/>
-            <a:chOff x="0" y="0"/>
-            <a:chExt cx="11049838" cy="667436"/>
-          </a:xfrm>
-        </p:grpSpPr>
-        <p:sp>
-          <p:nvSpPr>
-            <p:cNvPr name="Freeform 9" id="9"/>
-            <p:cNvSpPr/>
-            <p:nvPr/>
-          </p:nvSpPr>
-          <p:spPr>
-            <a:xfrm flipH="false" flipV="false" rot="0">
-              <a:off x="0" y="0"/>
-              <a:ext cx="11049889" cy="667385"/>
-            </a:xfrm>
-            <a:custGeom>
-              <a:avLst/>
-              <a:gdLst/>
-              <a:ahLst/>
-              <a:cxnLst/>
-              <a:rect r="r" b="b" t="t" l="l"/>
-              <a:pathLst>
-                <a:path h="667385" w="11049889">
-                  <a:moveTo>
-                    <a:pt x="0" y="0"/>
-                  </a:moveTo>
-                  <a:lnTo>
-                    <a:pt x="11049889" y="0"/>
-                  </a:lnTo>
-                  <a:lnTo>
-                    <a:pt x="11049889" y="667385"/>
-                  </a:lnTo>
-                  <a:lnTo>
-                    <a:pt x="0" y="667385"/>
-                  </a:lnTo>
-                  <a:lnTo>
-                    <a:pt x="0" y="0"/>
-                  </a:lnTo>
-                  <a:close/>
-                </a:path>
-              </a:pathLst>
-            </a:custGeom>
-            <a:solidFill>
-              <a:srgbClr val="1F4E79"/>
-            </a:solidFill>
-          </p:spPr>
-        </p:sp>
-      </p:grpSp>
       <p:sp>
         <p:nvSpPr>
-          <p:cNvPr name="TextBox 10" id="10"/>
+          <p:cNvPr name="TextBox 8" id="8"/>
           <p:cNvSpPr txBox="true"/>
           <p:nvPr/>
         </p:nvSpPr>
         <p:spPr>
           <a:xfrm rot="0">
-            <a:off x="6077321" y="1126405"/>
-            <a:ext cx="6475363" cy="666750"/>
+            <a:off x="5526584" y="4800600"/>
+            <a:ext cx="7234833" cy="666750"/>
           </a:xfrm>
           <a:prstGeom prst="rect">
             <a:avLst/>
@@ -12082,246 +12878,21 @@
             <a:r>
               <a:rPr lang="en-US" b="true" sz="4275" spc="-1">
                 <a:solidFill>
-                  <a:srgbClr val="1F4E79"/>
+                  <a:srgbClr val="C00000"/>
                 </a:solidFill>
                 <a:latin typeface="Arial Bold"/>
                 <a:ea typeface="Arial Bold"/>
                 <a:cs typeface="Arial Bold"/>
                 <a:sym typeface="Arial Bold"/>
               </a:rPr>
-              <a:t>Giới hạn của hai công cụ</a:t>
-            </a:r>
-          </a:p>
-        </p:txBody>
-      </p:sp>
-      <p:sp>
-        <p:nvSpPr>
-          <p:cNvPr name="TextBox 11" id="11"/>
-          <p:cNvSpPr txBox="true"/>
-          <p:nvPr/>
-        </p:nvSpPr>
-        <p:spPr>
-          <a:xfrm rot="0">
-            <a:off x="4323778" y="3231013"/>
-            <a:ext cx="1011422" cy="314087"/>
-          </a:xfrm>
-          <a:prstGeom prst="rect">
-            <a:avLst/>
-          </a:prstGeom>
-        </p:spPr>
-        <p:txBody>
-          <a:bodyPr anchor="t" rtlCol="false" tIns="0" lIns="0" bIns="0" rIns="0">
-            <a:spAutoFit/>
-          </a:bodyPr>
-          <a:lstStyle/>
-          <a:p>
-            <a:pPr algn="l">
-              <a:lnSpc>
-                <a:spcPts val="2574"/>
-              </a:lnSpc>
-            </a:pPr>
-            <a:r>
-              <a:rPr lang="en-US" b="true" sz="2145" spc="-1">
-                <a:solidFill>
-                  <a:srgbClr val="FFFFFF"/>
-                </a:solidFill>
-                <a:latin typeface="Arial Bold"/>
-                <a:ea typeface="Arial Bold"/>
-                <a:cs typeface="Arial Bold"/>
-                <a:sym typeface="Arial Bold"/>
-              </a:rPr>
-              <a:t>Appium</a:t>
-            </a:r>
-          </a:p>
-        </p:txBody>
-      </p:sp>
-      <p:sp>
-        <p:nvSpPr>
-          <p:cNvPr name="TextBox 12" id="12"/>
-          <p:cNvSpPr txBox="true"/>
-          <p:nvPr/>
-        </p:nvSpPr>
-        <p:spPr>
-          <a:xfrm rot="0">
-            <a:off x="685800" y="3795512"/>
-            <a:ext cx="8057772" cy="2124075"/>
-          </a:xfrm>
-          <a:prstGeom prst="rect">
-            <a:avLst/>
-          </a:prstGeom>
-        </p:spPr>
-        <p:txBody>
-          <a:bodyPr anchor="t" rtlCol="false" tIns="0" lIns="0" bIns="0" rIns="0">
-            <a:spAutoFit/>
-          </a:bodyPr>
-          <a:lstStyle/>
-          <a:p>
-            <a:pPr algn="l" marL="511683" indent="-255842" lvl="1">
-              <a:lnSpc>
-                <a:spcPts val="2844"/>
-              </a:lnSpc>
-              <a:buFont typeface="Arial"/>
-              <a:buChar char="•"/>
-            </a:pPr>
-            <a:r>
-              <a:rPr lang="en-US" sz="2370">
-                <a:solidFill>
-                  <a:srgbClr val="222222"/>
-                </a:solidFill>
-                <a:latin typeface="Arial"/>
-                <a:ea typeface="Arial"/>
-                <a:cs typeface="Arial"/>
-                <a:sym typeface="Arial"/>
-              </a:rPr>
-              <a:t>Không tự đánh giá giao diện – Functional tests có thể pass dù UI hiển thị sai.</a:t>
-            </a:r>
-          </a:p>
-          <a:p>
-            <a:pPr algn="l" marL="511683" indent="-255842" lvl="1">
-              <a:lnSpc>
-                <a:spcPts val="2844"/>
-              </a:lnSpc>
-              <a:buFont typeface="Arial"/>
-              <a:buChar char="•"/>
-            </a:pPr>
-            <a:r>
-              <a:rPr lang="en-US" sz="2370">
-                <a:solidFill>
-                  <a:srgbClr val="222222"/>
-                </a:solidFill>
-                <a:latin typeface="Arial"/>
-                <a:ea typeface="Arial"/>
-                <a:cs typeface="Arial"/>
-                <a:sym typeface="Arial"/>
-              </a:rPr>
-              <a:t>Nhạy cảm với thay đổi UI – Test scripts có thể cần bảo trì khi locators thay đổi.</a:t>
-            </a:r>
-          </a:p>
-          <a:p>
-            <a:pPr algn="l" marL="511683" indent="-255842" lvl="1">
-              <a:lnSpc>
-                <a:spcPts val="2844"/>
-              </a:lnSpc>
-              <a:buFont typeface="Arial"/>
-              <a:buChar char="•"/>
-            </a:pPr>
-            <a:r>
-              <a:rPr lang="en-US" sz="2370" spc="-1">
-                <a:solidFill>
-                  <a:srgbClr val="222222"/>
-                </a:solidFill>
-                <a:latin typeface="Arial"/>
-                <a:ea typeface="Arial"/>
-                <a:cs typeface="Arial"/>
-                <a:sym typeface="Arial"/>
-              </a:rPr>
-              <a:t>Phụ thuộc môi trường thực thi – Thiết bị, animation và thời gian tải có thể ảnh hưởng tính ổn định.</a:t>
+              <a:t>Visual Diff Triage Workshop</a:t>
             </a:r>
           </a:p>
         </p:txBody>
       </p:sp>
       <p:grpSp>
         <p:nvGrpSpPr>
-          <p:cNvPr name="Group 13" id="13"/>
-          <p:cNvGrpSpPr/>
-          <p:nvPr/>
-        </p:nvGrpSpPr>
-        <p:grpSpPr>
-          <a:xfrm rot="0">
-            <a:off x="9315002" y="3157376"/>
-            <a:ext cx="8287379" cy="500577"/>
-            <a:chOff x="0" y="0"/>
-            <a:chExt cx="11049838" cy="667436"/>
-          </a:xfrm>
-        </p:grpSpPr>
-        <p:sp>
-          <p:nvSpPr>
-            <p:cNvPr name="Freeform 14" id="14"/>
-            <p:cNvSpPr/>
-            <p:nvPr/>
-          </p:nvSpPr>
-          <p:spPr>
-            <a:xfrm flipH="false" flipV="false" rot="0">
-              <a:off x="0" y="0"/>
-              <a:ext cx="11049889" cy="667385"/>
-            </a:xfrm>
-            <a:custGeom>
-              <a:avLst/>
-              <a:gdLst/>
-              <a:ahLst/>
-              <a:cxnLst/>
-              <a:rect r="r" b="b" t="t" l="l"/>
-              <a:pathLst>
-                <a:path h="667385" w="11049889">
-                  <a:moveTo>
-                    <a:pt x="0" y="0"/>
-                  </a:moveTo>
-                  <a:lnTo>
-                    <a:pt x="11049889" y="0"/>
-                  </a:lnTo>
-                  <a:lnTo>
-                    <a:pt x="11049889" y="667385"/>
-                  </a:lnTo>
-                  <a:lnTo>
-                    <a:pt x="0" y="667385"/>
-                  </a:lnTo>
-                  <a:lnTo>
-                    <a:pt x="0" y="0"/>
-                  </a:lnTo>
-                  <a:close/>
-                </a:path>
-              </a:pathLst>
-            </a:custGeom>
-            <a:solidFill>
-              <a:srgbClr val="C00000"/>
-            </a:solidFill>
-          </p:spPr>
-        </p:sp>
-      </p:grpSp>
-      <p:sp>
-        <p:nvSpPr>
-          <p:cNvPr name="TextBox 15" id="15"/>
-          <p:cNvSpPr txBox="true"/>
-          <p:nvPr/>
-        </p:nvSpPr>
-        <p:spPr>
-          <a:xfrm rot="0">
-            <a:off x="12440517" y="3231013"/>
-            <a:ext cx="2040122" cy="314087"/>
-          </a:xfrm>
-          <a:prstGeom prst="rect">
-            <a:avLst/>
-          </a:prstGeom>
-        </p:spPr>
-        <p:txBody>
-          <a:bodyPr anchor="t" rtlCol="false" tIns="0" lIns="0" bIns="0" rIns="0">
-            <a:spAutoFit/>
-          </a:bodyPr>
-          <a:lstStyle/>
-          <a:p>
-            <a:pPr algn="l">
-              <a:lnSpc>
-                <a:spcPts val="2574"/>
-              </a:lnSpc>
-            </a:pPr>
-            <a:r>
-              <a:rPr lang="en-US" b="true" sz="2145" spc="-1">
-                <a:solidFill>
-                  <a:srgbClr val="FFFFFF"/>
-                </a:solidFill>
-                <a:latin typeface="Arial Bold"/>
-                <a:ea typeface="Arial Bold"/>
-                <a:cs typeface="Arial Bold"/>
-                <a:sym typeface="Arial Bold"/>
-              </a:rPr>
-              <a:t>Applitools Eyes</a:t>
-            </a:r>
-          </a:p>
-        </p:txBody>
-      </p:sp>
-      <p:grpSp>
-        <p:nvGrpSpPr>
-          <p:cNvPr name="Group 16" id="16"/>
+          <p:cNvPr name="Group 9" id="9"/>
           <p:cNvGrpSpPr/>
           <p:nvPr/>
         </p:nvGrpSpPr>
@@ -12335,7 +12906,7 @@
         </p:grpSpPr>
         <p:sp>
           <p:nvSpPr>
-            <p:cNvPr name="Freeform 17" id="17"/>
+            <p:cNvPr name="Freeform 10" id="10"/>
             <p:cNvSpPr/>
             <p:nvPr/>
           </p:nvSpPr>
@@ -12379,7 +12950,7 @@
       </p:grpSp>
       <p:grpSp>
         <p:nvGrpSpPr>
-          <p:cNvPr name="Group 18" id="18"/>
+          <p:cNvPr name="Group 11" id="11"/>
           <p:cNvGrpSpPr/>
           <p:nvPr/>
         </p:nvGrpSpPr>
@@ -12393,7 +12964,7 @@
         </p:grpSpPr>
         <p:sp>
           <p:nvSpPr>
-            <p:cNvPr name="Freeform 19" id="19"/>
+            <p:cNvPr name="Freeform 12" id="12"/>
             <p:cNvSpPr/>
             <p:nvPr/>
           </p:nvSpPr>
@@ -12437,7 +13008,7 @@
       </p:grpSp>
       <p:sp>
         <p:nvSpPr>
-          <p:cNvPr name="TextBox 20" id="20"/>
+          <p:cNvPr name="TextBox 13" id="13"/>
           <p:cNvSpPr txBox="true"/>
           <p:nvPr/>
         </p:nvSpPr>
@@ -12478,7 +13049,7 @@
       </p:sp>
       <p:sp>
         <p:nvSpPr>
-          <p:cNvPr name="TextBox 21" id="21"/>
+          <p:cNvPr name="TextBox 14" id="14"/>
           <p:cNvSpPr txBox="true"/>
           <p:nvPr/>
         </p:nvSpPr>
@@ -12512,92 +13083,7 @@
                 <a:cs typeface="Arial Bold"/>
                 <a:sym typeface="Arial Bold"/>
               </a:rPr>
-              <a:t>12 · Giới hạn</a:t>
-            </a:r>
-          </a:p>
-        </p:txBody>
-      </p:sp>
-      <p:sp>
-        <p:nvSpPr>
-          <p:cNvPr name="TextBox 22" id="22"/>
-          <p:cNvSpPr txBox="true"/>
-          <p:nvPr/>
-        </p:nvSpPr>
-        <p:spPr>
-          <a:xfrm rot="0">
-            <a:off x="9315002" y="3795512"/>
-            <a:ext cx="8057772" cy="2124075"/>
-          </a:xfrm>
-          <a:prstGeom prst="rect">
-            <a:avLst/>
-          </a:prstGeom>
-        </p:spPr>
-        <p:txBody>
-          <a:bodyPr anchor="t" rtlCol="false" tIns="0" lIns="0" bIns="0" rIns="0">
-            <a:spAutoFit/>
-          </a:bodyPr>
-          <a:lstStyle/>
-          <a:p>
-            <a:pPr algn="l" marL="511683" indent="-255842" lvl="1">
-              <a:lnSpc>
-                <a:spcPts val="2844"/>
-              </a:lnSpc>
-              <a:buFont typeface="Arial"/>
-              <a:buChar char="•"/>
-            </a:pPr>
-            <a:r>
-              <a:rPr lang="en-US" sz="2370">
-                <a:solidFill>
-                  <a:srgbClr val="222222"/>
-                </a:solidFill>
-                <a:latin typeface="Arial"/>
-                <a:ea typeface="Arial"/>
-                <a:cs typeface="Arial"/>
-                <a:sym typeface="Arial"/>
-              </a:rPr>
-              <a:t>Không kiểm tra đầy đủ chức năng – UI đúng không đảm bảo logic hoặc dữ liệu đúng.</a:t>
-            </a:r>
-          </a:p>
-          <a:p>
-            <a:pPr algn="l" marL="511683" indent="-255842" lvl="1">
-              <a:lnSpc>
-                <a:spcPts val="2844"/>
-              </a:lnSpc>
-              <a:buFont typeface="Arial"/>
-              <a:buChar char="•"/>
-            </a:pPr>
-            <a:r>
-              <a:rPr lang="en-US" sz="2370">
-                <a:solidFill>
-                  <a:srgbClr val="222222"/>
-                </a:solidFill>
-                <a:latin typeface="Arial"/>
-                <a:ea typeface="Arial"/>
-                <a:cs typeface="Arial"/>
-                <a:sym typeface="Arial"/>
-              </a:rPr>
-              <a:t>Cần phân biệt thay đổi và lỗi – Không phải visual difference nào cũng là bug.</a:t>
-            </a:r>
-          </a:p>
-          <a:p>
-            <a:pPr algn="l" marL="511683" indent="-255842" lvl="1">
-              <a:lnSpc>
-                <a:spcPts val="2844"/>
-              </a:lnSpc>
-              <a:buFont typeface="Arial"/>
-              <a:buChar char="•"/>
-            </a:pPr>
-            <a:r>
-              <a:rPr lang="en-US" sz="2370" spc="-1">
-                <a:solidFill>
-                  <a:srgbClr val="222222"/>
-                </a:solidFill>
-                <a:latin typeface="Arial"/>
-                <a:ea typeface="Arial"/>
-                <a:cs typeface="Arial"/>
-                <a:sym typeface="Arial"/>
-              </a:rPr>
-              <a:t>Cần quản lý baseline – Những thay đổi thiết kế hợp lệ phải được review và cập nhật.</a:t>
+              <a:t>13 · Hoạt động lớp</a:t>
             </a:r>
           </a:p>
         </p:txBody>
@@ -12812,8 +13298,8 @@
         </p:nvSpPr>
         <p:spPr>
           <a:xfrm rot="0">
-            <a:off x="5526584" y="4800600"/>
-            <a:ext cx="7234833" cy="666750"/>
+            <a:off x="6527872" y="3363276"/>
+            <a:ext cx="5232255" cy="2693214"/>
           </a:xfrm>
           <a:prstGeom prst="rect">
             <a:avLst/>
@@ -12827,20 +13313,20 @@
           <a:p>
             <a:pPr algn="l">
               <a:lnSpc>
-                <a:spcPts val="5130"/>
+                <a:spcPts val="22299"/>
               </a:lnSpc>
             </a:pPr>
             <a:r>
-              <a:rPr lang="en-US" b="true" sz="4275" spc="-1">
-                <a:solidFill>
-                  <a:srgbClr val="C00000"/>
+              <a:rPr lang="en-US" b="true" sz="18583" spc="-6">
+                <a:solidFill>
+                  <a:srgbClr val="1F4E79"/>
                 </a:solidFill>
                 <a:latin typeface="Arial Bold"/>
                 <a:ea typeface="Arial Bold"/>
                 <a:cs typeface="Arial Bold"/>
                 <a:sym typeface="Arial Bold"/>
               </a:rPr>
-              <a:t>Visual Diff Triage Workshop</a:t>
+              <a:t>Q&amp;A</a:t>
             </a:r>
           </a:p>
         </p:txBody>
@@ -13038,448 +13524,52 @@
                 <a:cs typeface="Arial Bold"/>
                 <a:sym typeface="Arial Bold"/>
               </a:rPr>
-              <a:t>13 · Hoạt động lớp</a:t>
-            </a:r>
-          </a:p>
-        </p:txBody>
-      </p:sp>
-    </p:spTree>
-  </p:cSld>
-  <p:clrMapOvr>
-    <a:masterClrMapping/>
-  </p:clrMapOvr>
-  <p:transition spd="fast">
-    <p:fade/>
-  </p:transition>
-</p:sld>
-</file>
-
-<file path=ppt/slides/slide15.xml><?xml version="1.0" encoding="utf-8"?>
-<p:sld xmlns:p="http://schemas.openxmlformats.org/presentationml/2006/main" xmlns:a="http://schemas.openxmlformats.org/drawingml/2006/main">
-  <p:cSld>
-    <p:spTree>
-      <p:nvGrpSpPr>
-        <p:cNvPr id="1" name=""/>
-        <p:cNvGrpSpPr/>
-        <p:nvPr/>
-      </p:nvGrpSpPr>
-      <p:grpSpPr>
-        <a:xfrm>
-          <a:off x="0" y="0"/>
-          <a:ext cx="0" cy="0"/>
-          <a:chOff x="0" y="0"/>
-          <a:chExt cx="0" cy="0"/>
-        </a:xfrm>
-      </p:grpSpPr>
-      <p:grpSp>
-        <p:nvGrpSpPr>
-          <p:cNvPr name="Group 2" id="2"/>
-          <p:cNvGrpSpPr/>
-          <p:nvPr/>
-        </p:nvGrpSpPr>
-        <p:grpSpPr>
-          <a:xfrm rot="0">
-            <a:off x="0" y="0"/>
-            <a:ext cx="18288181" cy="10287000"/>
-            <a:chOff x="0" y="0"/>
-            <a:chExt cx="24384241" cy="13716000"/>
-          </a:xfrm>
-        </p:grpSpPr>
-        <p:sp>
-          <p:nvSpPr>
-            <p:cNvPr name="Freeform 3" id="3"/>
-            <p:cNvSpPr/>
-            <p:nvPr/>
-          </p:nvSpPr>
-          <p:spPr>
-            <a:xfrm flipH="false" flipV="false" rot="0">
-              <a:off x="0" y="0"/>
-              <a:ext cx="24384254" cy="13716000"/>
-            </a:xfrm>
-            <a:custGeom>
-              <a:avLst/>
-              <a:gdLst/>
-              <a:ahLst/>
-              <a:cxnLst/>
-              <a:rect r="r" b="b" t="t" l="l"/>
-              <a:pathLst>
-                <a:path h="13716000" w="24384254">
-                  <a:moveTo>
-                    <a:pt x="0" y="0"/>
-                  </a:moveTo>
-                  <a:lnTo>
-                    <a:pt x="24384254" y="0"/>
-                  </a:lnTo>
-                  <a:lnTo>
-                    <a:pt x="24384254" y="13716000"/>
-                  </a:lnTo>
-                  <a:lnTo>
-                    <a:pt x="0" y="13716000"/>
-                  </a:lnTo>
-                  <a:lnTo>
-                    <a:pt x="0" y="0"/>
-                  </a:lnTo>
-                  <a:close/>
-                </a:path>
-              </a:pathLst>
-            </a:custGeom>
-            <a:solidFill>
-              <a:srgbClr val="FFFFFF"/>
-            </a:solidFill>
-          </p:spPr>
-        </p:sp>
-      </p:grpSp>
-      <p:grpSp>
-        <p:nvGrpSpPr>
-          <p:cNvPr name="Group 4" id="4"/>
-          <p:cNvGrpSpPr/>
-          <p:nvPr/>
-        </p:nvGrpSpPr>
-        <p:grpSpPr>
-          <a:xfrm rot="0">
-            <a:off x="0" y="0"/>
-            <a:ext cx="18288181" cy="10287000"/>
-            <a:chOff x="0" y="0"/>
-            <a:chExt cx="24384241" cy="13716000"/>
-          </a:xfrm>
-        </p:grpSpPr>
-        <p:sp>
-          <p:nvSpPr>
-            <p:cNvPr name="Freeform 5" id="5"/>
-            <p:cNvSpPr/>
-            <p:nvPr/>
-          </p:nvSpPr>
-          <p:spPr>
-            <a:xfrm flipH="false" flipV="false" rot="0">
-              <a:off x="0" y="0"/>
-              <a:ext cx="24384254" cy="13716000"/>
-            </a:xfrm>
-            <a:custGeom>
-              <a:avLst/>
-              <a:gdLst/>
-              <a:ahLst/>
-              <a:cxnLst/>
-              <a:rect r="r" b="b" t="t" l="l"/>
-              <a:pathLst>
-                <a:path h="13716000" w="24384254">
-                  <a:moveTo>
-                    <a:pt x="0" y="0"/>
-                  </a:moveTo>
-                  <a:lnTo>
-                    <a:pt x="24384254" y="0"/>
-                  </a:lnTo>
-                  <a:lnTo>
-                    <a:pt x="24384254" y="13716000"/>
-                  </a:lnTo>
-                  <a:lnTo>
-                    <a:pt x="0" y="13716000"/>
-                  </a:lnTo>
-                  <a:lnTo>
-                    <a:pt x="0" y="0"/>
-                  </a:lnTo>
-                  <a:close/>
-                </a:path>
-              </a:pathLst>
-            </a:custGeom>
-            <a:solidFill>
-              <a:srgbClr val="FFFFFF"/>
-            </a:solidFill>
-          </p:spPr>
-        </p:sp>
-      </p:grpSp>
-      <p:grpSp>
-        <p:nvGrpSpPr>
-          <p:cNvPr name="Group 6" id="6"/>
-          <p:cNvGrpSpPr/>
-          <p:nvPr/>
-        </p:nvGrpSpPr>
-        <p:grpSpPr>
-          <a:xfrm rot="0">
-            <a:off x="0" y="0"/>
-            <a:ext cx="18288181" cy="10287000"/>
-            <a:chOff x="0" y="0"/>
-            <a:chExt cx="24384241" cy="13716000"/>
-          </a:xfrm>
-        </p:grpSpPr>
-        <p:sp>
-          <p:nvSpPr>
-            <p:cNvPr name="Freeform 7" id="7"/>
-            <p:cNvSpPr/>
-            <p:nvPr/>
-          </p:nvSpPr>
-          <p:spPr>
-            <a:xfrm flipH="false" flipV="false" rot="0">
-              <a:off x="0" y="0"/>
-              <a:ext cx="24384254" cy="13716000"/>
-            </a:xfrm>
-            <a:custGeom>
-              <a:avLst/>
-              <a:gdLst/>
-              <a:ahLst/>
-              <a:cxnLst/>
-              <a:rect r="r" b="b" t="t" l="l"/>
-              <a:pathLst>
-                <a:path h="13716000" w="24384254">
-                  <a:moveTo>
-                    <a:pt x="0" y="0"/>
-                  </a:moveTo>
-                  <a:lnTo>
-                    <a:pt x="24384254" y="0"/>
-                  </a:lnTo>
-                  <a:lnTo>
-                    <a:pt x="24384254" y="13716000"/>
-                  </a:lnTo>
-                  <a:lnTo>
-                    <a:pt x="0" y="13716000"/>
-                  </a:lnTo>
-                  <a:lnTo>
-                    <a:pt x="0" y="0"/>
-                  </a:lnTo>
-                  <a:close/>
-                </a:path>
-              </a:pathLst>
-            </a:custGeom>
-            <a:solidFill>
-              <a:srgbClr val="FFFFFF"/>
-            </a:solidFill>
-          </p:spPr>
-        </p:sp>
-      </p:grpSp>
-      <p:sp>
-        <p:nvSpPr>
-          <p:cNvPr name="TextBox 8" id="8"/>
-          <p:cNvSpPr txBox="true"/>
-          <p:nvPr/>
-        </p:nvSpPr>
-        <p:spPr>
-          <a:xfrm rot="0">
-            <a:off x="6527872" y="3363276"/>
-            <a:ext cx="5232255" cy="2693214"/>
-          </a:xfrm>
-          <a:prstGeom prst="rect">
-            <a:avLst/>
-          </a:prstGeom>
-        </p:spPr>
-        <p:txBody>
-          <a:bodyPr anchor="t" rtlCol="false" tIns="0" lIns="0" bIns="0" rIns="0">
-            <a:spAutoFit/>
-          </a:bodyPr>
-          <a:lstStyle/>
-          <a:p>
-            <a:pPr algn="l">
-              <a:lnSpc>
-                <a:spcPts val="22299"/>
-              </a:lnSpc>
-            </a:pPr>
-            <a:r>
-              <a:rPr lang="en-US" b="true" sz="18583" spc="-6">
-                <a:solidFill>
-                  <a:srgbClr val="1F4E79"/>
-                </a:solidFill>
-                <a:latin typeface="Arial Bold"/>
-                <a:ea typeface="Arial Bold"/>
-                <a:cs typeface="Arial Bold"/>
-                <a:sym typeface="Arial Bold"/>
-              </a:rPr>
-              <a:t>Q&amp;A</a:t>
-            </a:r>
-          </a:p>
-        </p:txBody>
-      </p:sp>
-      <p:grpSp>
-        <p:nvGrpSpPr>
-          <p:cNvPr name="Group 9" id="9"/>
-          <p:cNvGrpSpPr/>
-          <p:nvPr/>
-        </p:nvGrpSpPr>
-        <p:grpSpPr>
-          <a:xfrm rot="0">
-            <a:off x="0" y="0"/>
-            <a:ext cx="18288181" cy="143104"/>
-            <a:chOff x="0" y="0"/>
-            <a:chExt cx="24384241" cy="190805"/>
-          </a:xfrm>
-        </p:grpSpPr>
-        <p:sp>
-          <p:nvSpPr>
-            <p:cNvPr name="Freeform 10" id="10"/>
-            <p:cNvSpPr/>
-            <p:nvPr/>
-          </p:nvSpPr>
-          <p:spPr>
-            <a:xfrm flipH="false" flipV="false" rot="0">
-              <a:off x="0" y="0"/>
-              <a:ext cx="24384254" cy="190754"/>
-            </a:xfrm>
-            <a:custGeom>
-              <a:avLst/>
-              <a:gdLst/>
-              <a:ahLst/>
-              <a:cxnLst/>
-              <a:rect r="r" b="b" t="t" l="l"/>
-              <a:pathLst>
-                <a:path h="190754" w="24384254">
-                  <a:moveTo>
-                    <a:pt x="0" y="0"/>
-                  </a:moveTo>
-                  <a:lnTo>
-                    <a:pt x="24384254" y="0"/>
-                  </a:lnTo>
-                  <a:lnTo>
-                    <a:pt x="24384254" y="190754"/>
-                  </a:lnTo>
-                  <a:lnTo>
-                    <a:pt x="0" y="190754"/>
-                  </a:lnTo>
-                  <a:lnTo>
-                    <a:pt x="0" y="0"/>
-                  </a:lnTo>
-                  <a:close/>
-                </a:path>
-              </a:pathLst>
-            </a:custGeom>
-            <a:solidFill>
-              <a:srgbClr val="1F4E79"/>
-            </a:solidFill>
-          </p:spPr>
-        </p:sp>
-      </p:grpSp>
-      <p:grpSp>
-        <p:nvGrpSpPr>
-          <p:cNvPr name="Group 11" id="11"/>
-          <p:cNvGrpSpPr/>
-          <p:nvPr/>
-        </p:nvGrpSpPr>
-        <p:grpSpPr>
-          <a:xfrm rot="0">
-            <a:off x="0" y="9943557"/>
-            <a:ext cx="18288181" cy="343443"/>
-            <a:chOff x="0" y="0"/>
-            <a:chExt cx="24384241" cy="457924"/>
-          </a:xfrm>
-        </p:grpSpPr>
-        <p:sp>
-          <p:nvSpPr>
-            <p:cNvPr name="Freeform 12" id="12"/>
-            <p:cNvSpPr/>
-            <p:nvPr/>
-          </p:nvSpPr>
-          <p:spPr>
-            <a:xfrm flipH="false" flipV="false" rot="0">
-              <a:off x="0" y="0"/>
-              <a:ext cx="24384254" cy="457962"/>
-            </a:xfrm>
-            <a:custGeom>
-              <a:avLst/>
-              <a:gdLst/>
-              <a:ahLst/>
-              <a:cxnLst/>
-              <a:rect r="r" b="b" t="t" l="l"/>
-              <a:pathLst>
-                <a:path h="457962" w="24384254">
-                  <a:moveTo>
-                    <a:pt x="0" y="0"/>
-                  </a:moveTo>
-                  <a:lnTo>
-                    <a:pt x="24384254" y="0"/>
-                  </a:lnTo>
-                  <a:lnTo>
-                    <a:pt x="24384254" y="457962"/>
-                  </a:lnTo>
-                  <a:lnTo>
-                    <a:pt x="0" y="457962"/>
-                  </a:lnTo>
-                  <a:lnTo>
-                    <a:pt x="0" y="0"/>
-                  </a:lnTo>
-                  <a:close/>
-                </a:path>
-              </a:pathLst>
-            </a:custGeom>
-            <a:solidFill>
-              <a:srgbClr val="1F4E79"/>
-            </a:solidFill>
-          </p:spPr>
-        </p:sp>
-      </p:grpSp>
-      <p:sp>
-        <p:nvSpPr>
-          <p:cNvPr name="TextBox 13" id="13"/>
-          <p:cNvSpPr txBox="true"/>
-          <p:nvPr/>
-        </p:nvSpPr>
-        <p:spPr>
-          <a:xfrm rot="0">
-            <a:off x="685800" y="250755"/>
-            <a:ext cx="4865942" cy="215808"/>
-          </a:xfrm>
-          <a:prstGeom prst="rect">
-            <a:avLst/>
-          </a:prstGeom>
-        </p:spPr>
-        <p:txBody>
-          <a:bodyPr anchor="t" rtlCol="false" tIns="0" lIns="0" bIns="0" rIns="0">
-            <a:spAutoFit/>
-          </a:bodyPr>
-          <a:lstStyle/>
-          <a:p>
-            <a:pPr algn="l">
-              <a:lnSpc>
-                <a:spcPts val="1764"/>
-              </a:lnSpc>
-            </a:pPr>
-            <a:r>
-              <a:rPr lang="en-US" b="true" sz="1470" spc="-1">
-                <a:solidFill>
-                  <a:srgbClr val="1F4E79"/>
-                </a:solidFill>
-                <a:latin typeface="Arial Bold"/>
-                <a:ea typeface="Arial Bold"/>
-                <a:cs typeface="Arial Bold"/>
-                <a:sym typeface="Arial Bold"/>
-              </a:rPr>
-              <a:t>2026 AI-first · Seminar T03 · Mobile Automation Testing</a:t>
+              <a:t>14 · Q&amp;A</a:t>
             </a:r>
           </a:p>
         </p:txBody>
       </p:sp>
       <p:sp>
         <p:nvSpPr>
-          <p:cNvPr name="TextBox 14" id="14"/>
-          <p:cNvSpPr txBox="true"/>
+          <p:cNvPr id="15" name="TextBox 14"/>
+          <p:cNvSpPr txBox="1"/>
           <p:nvPr/>
         </p:nvSpPr>
         <p:spPr>
-          <a:xfrm rot="0">
-            <a:off x="685800" y="9998488"/>
-            <a:ext cx="9144000" cy="211826"/>
+          <a:xfrm>
+            <a:off x="2743200" y="6400800"/>
+            <a:ext cx="12801600" cy="548640"/>
           </a:xfrm>
           <a:prstGeom prst="rect">
             <a:avLst/>
           </a:prstGeom>
+          <a:noFill/>
         </p:spPr>
         <p:txBody>
-          <a:bodyPr anchor="t" rtlCol="false" tIns="0" lIns="0" bIns="0" rIns="0" wrap="square">
-            <a:noAutofit/>
+          <a:bodyPr wrap="square">
+            <a:spAutoFit/>
           </a:bodyPr>
           <a:lstStyle/>
           <a:p>
-            <a:pPr algn="l">
-              <a:lnSpc>
-                <a:spcPts val="1620"/>
-              </a:lnSpc>
-            </a:pPr>
-            <a:r>
-              <a:rPr lang="en-US" b="true" sz="1350" spc="-1">
-                <a:solidFill>
-                  <a:srgbClr val="FFFFFF"/>
-                </a:solidFill>
-                <a:latin typeface="Arial Bold"/>
-                <a:ea typeface="Arial Bold"/>
-                <a:cs typeface="Arial Bold"/>
-                <a:sym typeface="Arial Bold"/>
-              </a:rPr>
-              <a:t>14 · Q&amp;A</a:t>
+            <a:pPr algn="ctr"/>
+            <a:r>
+              <a:rPr sz="2200" b="1">
+                <a:solidFill>
+                  <a:srgbClr val="1F4E79"/>
+                </a:solidFill>
+                <a:latin typeface="Arial"/>
+              </a:rPr>
+              <a:t>Video demo: </a:t>
+            </a:r>
+            <a:r>
+              <a:rPr sz="2200" b="1">
+                <a:solidFill>
+                  <a:srgbClr val="1F4E79"/>
+                </a:solidFill>
+                <a:latin typeface="Arial"/>
+                <a:hlinkClick xmlns:ns0="http://schemas.openxmlformats.org/officeDocument/2006/relationships" ns0:id="rId2"/>
+              </a:rPr>
+              <a:t>https://youtu.be/N3cN5d2LSG4</a:t>
             </a:r>
           </a:p>
         </p:txBody>

</xml_diff>

<commit_message>
docs(slides): replace the clip placeholder on slide 11 with the timed video link
Co-Authored-By: Claude Opus 5.5 <noreply@anthropic.com>
</commit_message>
<xml_diff>
--- a/slides/Seminar_Slides.pptx
+++ b/slides/Seminar_Slides.pptx
@@ -11692,8 +11692,9 @@
                 <a:ea typeface="Arial Bold"/>
                 <a:cs typeface="Arial Bold"/>
                 <a:sym typeface="Arial Bold"/>
-              </a:rPr>
-              <a:t>[link + mốc thời gian]</a:t>
+                <a:hlinkClick r:id="rId9"/>
+              </a:rPr>
+              <a:t>youtu.be/N3cN5d2LSG4 (4:06)</a:t>
             </a:r>
           </a:p>
         </p:txBody>

</xml_diff>

<commit_message>
docs(slides): reorder Appium deck and clarify data-driven Pass/Fail
Co-authored-by: Cursor <cursoragent@cursor.com>
</commit_message>
<xml_diff>
--- a/slides/Seminar_Slides.pptx
+++ b/slides/Seminar_Slides.pptx
@@ -21,9 +21,11 @@
     <p:sldId id="269" r:id="rId15"/>
     <p:sldId id="270" r:id="rId16"/>
     <p:sldId id="271" r:id="rId17"/>
+    <p:sldId id="272" r:id="rId18"/>
+    <p:sldId id="273" r:id="rId19"/>
   </p:sldIdLst>
   <p:notesMasterIdLst>
-    <p:notesMasterId r:id="rId18"/>
+    <p:notesMasterId r:id="rId20"/>
   </p:notesMasterIdLst>
   <p:sldSz cx="12192000" cy="6858000"/>
   <p:notesSz cx="6858000" cy="12192000"/>
@@ -1157,6 +1159,182 @@
             <a:fld id="{F7021451-1387-4CA6-816F-3879F97B5CBC}" type="slidenum">
               <a:rPr lang="en-US"/>
               <a:t>16</a:t>
+            </a:fld>
+            <a:endParaRPr lang="en-US"/>
+          </a:p>
+        </p:txBody>
+      </p:sp>
+    </p:spTree>
+    <p:extLst>
+      <p:ext uri="{BB962C8B-B14F-4D97-AF65-F5344CB8AC3E}">
+        <p14:creationId xmlns:p14="http://schemas.microsoft.com/office/powerpoint/2010/main" val="1024086991"/>
+      </p:ext>
+    </p:extLst>
+  </p:cSld>
+  <p:clrMapOvr>
+    <a:masterClrMapping/>
+  </p:clrMapOvr>
+</p:notes>
+</file>
+
+<file path=ppt/notesSlides/notesSlide17.xml><?xml version="1.0" encoding="utf-8"?>
+<p:notes xmlns:a="http://schemas.openxmlformats.org/drawingml/2006/main" xmlns:r="http://schemas.openxmlformats.org/officeDocument/2006/relationships" xmlns:p="http://schemas.openxmlformats.org/presentationml/2006/main">
+  <p:cSld>
+    <p:spTree>
+      <p:nvGrpSpPr>
+        <p:cNvPr id="1" name=""/>
+        <p:cNvGrpSpPr/>
+        <p:nvPr/>
+      </p:nvGrpSpPr>
+      <p:grpSpPr>
+        <a:xfrm>
+          <a:off x="0" y="0"/>
+          <a:ext cx="0" cy="0"/>
+          <a:chOff x="0" y="0"/>
+          <a:chExt cx="0" cy="0"/>
+        </a:xfrm>
+      </p:grpSpPr>
+      <p:sp>
+        <p:nvSpPr>
+          <p:cNvPr id="2" name="Slide Image Placeholder 1"/>
+          <p:cNvSpPr>
+            <a:spLocks noGrp="1" noRot="1" noChangeAspect="1"/>
+          </p:cNvSpPr>
+          <p:nvPr>
+            <p:ph type="sldImg"/>
+          </p:nvPr>
+        </p:nvSpPr>
+        <p:spPr/>
+      </p:sp>
+      <p:sp>
+        <p:nvSpPr>
+          <p:cNvPr id="3" name="Notes Placeholder 2"/>
+          <p:cNvSpPr>
+            <a:spLocks noGrp="1"/>
+          </p:cNvSpPr>
+          <p:nvPr>
+            <p:ph type="body" idx="1"/>
+          </p:nvPr>
+        </p:nvSpPr>
+        <p:spPr/>
+        <p:txBody>
+          <a:bodyPr/>
+          <a:lstStyle/>
+          <a:p>
+            <a:r>
+              <a:rPr lang="en-US" dirty="0"/>
+              <a:t/>
+            </a:r>
+            <a:endParaRPr lang="en-US" dirty="0"/>
+          </a:p>
+        </p:txBody>
+      </p:sp>
+      <p:sp>
+        <p:nvSpPr>
+          <p:cNvPr id="4" name="Slide Number Placeholder 3"/>
+          <p:cNvSpPr>
+            <a:spLocks noGrp="1"/>
+          </p:cNvSpPr>
+          <p:nvPr>
+            <p:ph type="sldNum" sz="quarter" idx="10"/>
+          </p:nvPr>
+        </p:nvSpPr>
+        <p:spPr/>
+        <p:txBody>
+          <a:bodyPr/>
+          <a:lstStyle/>
+          <a:p>
+            <a:fld id="{F7021451-1387-4CA6-816F-3879F97B5CBC}" type="slidenum">
+              <a:rPr lang="en-US"/>
+              <a:t>17</a:t>
+            </a:fld>
+            <a:endParaRPr lang="en-US"/>
+          </a:p>
+        </p:txBody>
+      </p:sp>
+    </p:spTree>
+    <p:extLst>
+      <p:ext uri="{BB962C8B-B14F-4D97-AF65-F5344CB8AC3E}">
+        <p14:creationId xmlns:p14="http://schemas.microsoft.com/office/powerpoint/2010/main" val="1024086991"/>
+      </p:ext>
+    </p:extLst>
+  </p:cSld>
+  <p:clrMapOvr>
+    <a:masterClrMapping/>
+  </p:clrMapOvr>
+</p:notes>
+</file>
+
+<file path=ppt/notesSlides/notesSlide18.xml><?xml version="1.0" encoding="utf-8"?>
+<p:notes xmlns:a="http://schemas.openxmlformats.org/drawingml/2006/main" xmlns:r="http://schemas.openxmlformats.org/officeDocument/2006/relationships" xmlns:p="http://schemas.openxmlformats.org/presentationml/2006/main">
+  <p:cSld>
+    <p:spTree>
+      <p:nvGrpSpPr>
+        <p:cNvPr id="1" name=""/>
+        <p:cNvGrpSpPr/>
+        <p:nvPr/>
+      </p:nvGrpSpPr>
+      <p:grpSpPr>
+        <a:xfrm>
+          <a:off x="0" y="0"/>
+          <a:ext cx="0" cy="0"/>
+          <a:chOff x="0" y="0"/>
+          <a:chExt cx="0" cy="0"/>
+        </a:xfrm>
+      </p:grpSpPr>
+      <p:sp>
+        <p:nvSpPr>
+          <p:cNvPr id="2" name="Slide Image Placeholder 1"/>
+          <p:cNvSpPr>
+            <a:spLocks noGrp="1" noRot="1" noChangeAspect="1"/>
+          </p:cNvSpPr>
+          <p:nvPr>
+            <p:ph type="sldImg"/>
+          </p:nvPr>
+        </p:nvSpPr>
+        <p:spPr/>
+      </p:sp>
+      <p:sp>
+        <p:nvSpPr>
+          <p:cNvPr id="3" name="Notes Placeholder 2"/>
+          <p:cNvSpPr>
+            <a:spLocks noGrp="1"/>
+          </p:cNvSpPr>
+          <p:nvPr>
+            <p:ph type="body" idx="1"/>
+          </p:nvPr>
+        </p:nvSpPr>
+        <p:spPr/>
+        <p:txBody>
+          <a:bodyPr/>
+          <a:lstStyle/>
+          <a:p>
+            <a:r>
+              <a:rPr lang="en-US" dirty="0"/>
+              <a:t/>
+            </a:r>
+            <a:endParaRPr lang="en-US" dirty="0"/>
+          </a:p>
+        </p:txBody>
+      </p:sp>
+      <p:sp>
+        <p:nvSpPr>
+          <p:cNvPr id="4" name="Slide Number Placeholder 3"/>
+          <p:cNvSpPr>
+            <a:spLocks noGrp="1"/>
+          </p:cNvSpPr>
+          <p:nvPr>
+            <p:ph type="sldNum" sz="quarter" idx="10"/>
+          </p:nvPr>
+        </p:nvSpPr>
+        <p:spPr/>
+        <p:txBody>
+          <a:bodyPr/>
+          <a:lstStyle/>
+          <a:p>
+            <a:fld id="{F7021451-1387-4CA6-816F-3879F97B5CBC}" type="slidenum">
+              <a:rPr lang="en-US"/>
+              <a:t>18</a:t>
             </a:fld>
             <a:endParaRPr lang="en-US"/>
           </a:p>
@@ -2462,6 +2640,84 @@
 <file path=ppt/slides/slide16.xml><?xml version="1.0" encoding="utf-8"?>
 <p:sld xmlns:a="http://schemas.openxmlformats.org/drawingml/2006/main" xmlns:r="http://schemas.openxmlformats.org/officeDocument/2006/relationships" xmlns:p="http://schemas.openxmlformats.org/presentationml/2006/main">
   <p:cSld name="Slide 16">
+    <p:bg>
+      <p:bgPr>
+        <a:blipFill dpi="0" rotWithShape="1">
+          <a:blip r:embed="rId1">
+            <a:lum/>
+          </a:blip>
+          <a:srcRect/>
+          <a:stretch>
+            <a:fillRect/>
+          </a:stretch>
+        </a:blipFill>
+        <a:effectLst/>
+      </p:bgPr>
+    </p:bg>
+    <p:spTree>
+      <p:nvGrpSpPr>
+        <p:cNvPr id="1" name=""/>
+        <p:cNvGrpSpPr/>
+        <p:nvPr/>
+      </p:nvGrpSpPr>
+      <p:grpSpPr>
+        <a:xfrm>
+          <a:off x="0" y="0"/>
+          <a:ext cx="0" cy="0"/>
+          <a:chOff x="0" y="0"/>
+          <a:chExt cx="0" cy="0"/>
+        </a:xfrm>
+      </p:grpSpPr>
+    </p:spTree>
+  </p:cSld>
+  <p:clrMapOvr>
+    <a:masterClrMapping/>
+  </p:clrMapOvr>
+</p:sld>
+</file>
+
+<file path=ppt/slides/slide17.xml><?xml version="1.0" encoding="utf-8"?>
+<p:sld xmlns:a="http://schemas.openxmlformats.org/drawingml/2006/main" xmlns:r="http://schemas.openxmlformats.org/officeDocument/2006/relationships" xmlns:p="http://schemas.openxmlformats.org/presentationml/2006/main">
+  <p:cSld name="Slide 17">
+    <p:bg>
+      <p:bgPr>
+        <a:blipFill dpi="0" rotWithShape="1">
+          <a:blip r:embed="rId1">
+            <a:lum/>
+          </a:blip>
+          <a:srcRect/>
+          <a:stretch>
+            <a:fillRect/>
+          </a:stretch>
+        </a:blipFill>
+        <a:effectLst/>
+      </p:bgPr>
+    </p:bg>
+    <p:spTree>
+      <p:nvGrpSpPr>
+        <p:cNvPr id="1" name=""/>
+        <p:cNvGrpSpPr/>
+        <p:nvPr/>
+      </p:nvGrpSpPr>
+      <p:grpSpPr>
+        <a:xfrm>
+          <a:off x="0" y="0"/>
+          <a:ext cx="0" cy="0"/>
+          <a:chOff x="0" y="0"/>
+          <a:chExt cx="0" cy="0"/>
+        </a:xfrm>
+      </p:grpSpPr>
+    </p:spTree>
+  </p:cSld>
+  <p:clrMapOvr>
+    <a:masterClrMapping/>
+  </p:clrMapOvr>
+</p:sld>
+</file>
+
+<file path=ppt/slides/slide18.xml><?xml version="1.0" encoding="utf-8"?>
+<p:sld xmlns:a="http://schemas.openxmlformats.org/drawingml/2006/main" xmlns:r="http://schemas.openxmlformats.org/officeDocument/2006/relationships" xmlns:p="http://schemas.openxmlformats.org/presentationml/2006/main">
+  <p:cSld name="Slide 18">
     <p:bg>
       <p:bgPr>
         <a:blipFill dpi="0" rotWithShape="1">

</xml_diff>